<commit_message>
Final evidence, documentation and presentation
- Part 2 evidence rebuilt on receiver-side slot attribution (RxSlotStatusTable vs PHY transmissions)
- Runner hardening: schedule-acceptance gate, IPv6 off, PID namespace, exit checks, checksum
- New experiments: E4 high load, E5 free-space channel, 5-seed replication
- Stage 4/5 reports, FINAL_REPORT.md with traceability, updated documentation PDF and deck
- .gitattributes keeps scripts LF for Linux/WSL

Co-Authored-By: Claude Opus 5.5 <noreply@anthropic.com>
</commit_message>
<xml_diff>
--- a/presentation/TDMA_Schedule_Optimizer.pptx
+++ b/presentation/TDMA_Schedule_Optimizer.pptx
@@ -125,7 +125,7 @@
   <p:extLst>
     <p:ext uri="{521415D9-36F7-43E2-AB2F-B90AF26B5E84}">
       <p14:sectionLst xmlns:p14="http://schemas.microsoft.com/office/powerpoint/2010/main">
-        <p14:section name="Introduction" id="{29416ef5-d041-0bac-3e5c-30454d31e8e1}">
+        <p14:section name="Introduction" id="{a5a5aad0-be7c-46cd-f58e-a025754bd66c}">
           <p14:sldIdLst>
             <p14:sldId id="256"/>
             <p14:sldId id="257"/>
@@ -133,7 +133,7 @@
             <p14:sldId id="259"/>
           </p14:sldIdLst>
         </p14:section>
-        <p14:section name="Part 1: the Brain" id="{71997b6a-d0dd-fe3d-5ec4-1b1cecbd3c95}">
+        <p14:section name="Part 1: the Brain" id="{c6524935-9afb-7eda-ca2e-ce572457d7f9}">
           <p14:sldIdLst>
             <p14:sldId id="260"/>
             <p14:sldId id="261"/>
@@ -143,7 +143,7 @@
             <p14:sldId id="265"/>
           </p14:sldIdLst>
         </p14:section>
-        <p14:section name="Part 2: EMANE" id="{dcfccb07-7fce-480c-731f-6f15e3ad6cf6}">
+        <p14:section name="Part 2: EMANE" id="{39d0466c-2b1d-9fcc-b756-449cf9355dfd}">
           <p14:sldIdLst>
             <p14:sldId id="266"/>
             <p14:sldId id="267"/>
@@ -154,7 +154,7 @@
             <p14:sldId id="272"/>
           </p14:sldIdLst>
         </p14:section>
-        <p14:section name="Close" id="{b8678726-a811-5804-8e9e-2975e84f7711}">
+        <p14:section name="Close" id="{6117d913-0411-c545-27e7-e7e09d018a60}">
           <p14:sldIdLst>
             <p14:sldId id="273"/>
             <p14:sldId id="274"/>
@@ -1337,7 +1337,7 @@
           <a:p>
             <a:r>
               <a:rPr lang="en-US" dirty="0"/>
-              <a:t>Opening: the task is a centralised TDMA scheduler (Part 1, mandatory) plus EMANE enforcement (Part 2, bonus). Three headline numbers: 9 slots, proven minimal, for the sample grid; zero collisions confirmed three independent ways; and in EMANE the schedule is enforced, 99.96 % delivery on links and 0 % off-links.</a:t>
+              <a:t>Opening: the task is a centralised TDMA scheduler (Part 1, mandatory) plus EMANE enforcement (Part 2, bonus). Three headline numbers: 9 slots, proven minimal, for the sample grid; zero collisions confirmed three independent ways; and in EMANE the schedule is enforced: 99.88 % delivery on links, 0 % off-links, and every sender is heard only in its planned slot.</a:t>
             </a:r>
             <a:endParaRPr lang="en-US" dirty="0"/>
           </a:p>
@@ -18827,47 +18827,47 @@
 </file>
 
 <file path=ppt/theme/theme1.xml><?xml version="1.0" encoding="utf-8"?>
-<a:theme xmlns:a="http://schemas.openxmlformats.org/drawingml/2006/main" name="Office Theme">
+<a:theme xmlns:a="http://schemas.openxmlformats.org/drawingml/2006/main" name="VMN TDMA">
   <a:themeElements>
-    <a:clrScheme name="Office">
+    <a:clrScheme name="VMN TDMA">
       <a:dk1>
-        <a:sysClr val="windowText" lastClr="000000"/>
+        <a:srgbClr val="1E2A30"/>
       </a:dk1>
       <a:lt1>
-        <a:sysClr val="window" lastClr="FFFFFF"/>
+        <a:srgbClr val="FFFFFF"/>
       </a:lt1>
       <a:dk2>
-        <a:srgbClr val="44546A"/>
+        <a:srgbClr val="0B2A33"/>
       </a:dk2>
       <a:lt2>
-        <a:srgbClr val="E7E6E6"/>
+        <a:srgbClr val="EEF5F4"/>
       </a:lt2>
       <a:accent1>
-        <a:srgbClr val="4472C4"/>
+        <a:srgbClr val="12877F"/>
       </a:accent1>
       <a:accent2>
-        <a:srgbClr val="ED7D31"/>
+        <a:srgbClr val="E8A33D"/>
       </a:accent2>
       <a:accent3>
-        <a:srgbClr val="A5A5A5"/>
+        <a:srgbClr val="D9533A"/>
       </a:accent3>
       <a:accent4>
-        <a:srgbClr val="FFC000"/>
+        <a:srgbClr val="3E7CB1"/>
       </a:accent4>
       <a:accent5>
-        <a:srgbClr val="5B9BD5"/>
+        <a:srgbClr val="7A9E7E"/>
       </a:accent5>
       <a:accent6>
-        <a:srgbClr val="70AD47"/>
+        <a:srgbClr val="9AA5A8"/>
       </a:accent6>
       <a:hlink>
-        <a:srgbClr val="0563C1"/>
+        <a:srgbClr val="12877F"/>
       </a:hlink>
       <a:folHlink>
-        <a:srgbClr val="954F72"/>
+        <a:srgbClr val="5B6B70"/>
       </a:folHlink>
     </a:clrScheme>
-    <a:fontScheme name="Office">
+    <a:fontScheme name="VMN TDMA">
       <a:majorFont>
         <a:latin typeface="Cambria"/>
         <a:ea typeface=""/>

</xml_diff>